<commit_message>
PPTX: auto-skrump på KPI- og bignum-tal (robust uanset skrifttype)
Lange værdier krymper til at passe i kortet i stedet for at ombryde/flyde over.

Co-Authored-By: Claude Opus 4.8 <noreply@anthropic.com>
</commit_message>
<xml_diff>
--- a/morten-ds-example.pptx
+++ b/morten-ds-example.pptx
@@ -7548,8 +7548,8 @@
           <a:noFill/>
         </p:spPr>
         <p:txBody>
-          <a:bodyPr wrap="square">
-            <a:spAutoFit/>
+          <a:bodyPr wrap="none">
+            <a:normAutofit/>
           </a:bodyPr>
           <a:lstStyle/>
           <a:p>
@@ -11189,8 +11189,8 @@
           <a:noFill/>
         </p:spPr>
         <p:txBody>
-          <a:bodyPr wrap="square">
-            <a:spAutoFit/>
+          <a:bodyPr wrap="none">
+            <a:normAutofit/>
           </a:bodyPr>
           <a:lstStyle/>
           <a:p>
@@ -11313,8 +11313,8 @@
           <a:noFill/>
         </p:spPr>
         <p:txBody>
-          <a:bodyPr wrap="square">
-            <a:spAutoFit/>
+          <a:bodyPr wrap="none">
+            <a:normAutofit/>
           </a:bodyPr>
           <a:lstStyle/>
           <a:p>
@@ -11437,8 +11437,8 @@
           <a:noFill/>
         </p:spPr>
         <p:txBody>
-          <a:bodyPr wrap="square">
-            <a:spAutoFit/>
+          <a:bodyPr wrap="none">
+            <a:normAutofit/>
           </a:bodyPr>
           <a:lstStyle/>
           <a:p>

</xml_diff>

<commit_message>
Fjern side-nummer (footer + HUD-tæller) i HTML og PPTX
Behold deck-titel/logo i footer og den diskrete fremdrifts-bjælke.

Co-Authored-By: Claude Opus 4.8 <noreply@anthropic.com>
</commit_message>
<xml_diff>
--- a/morten-ds-example.pptx
+++ b/morten-ds-example.pptx
@@ -3327,41 +3327,6 @@
           </a:p>
         </p:txBody>
       </p:sp>
-      <p:sp>
-        <p:nvSpPr>
-          <p:cNvPr id="6" name="TextBox 5"/>
-          <p:cNvSpPr txBox="1"/>
-          <p:nvPr/>
-        </p:nvSpPr>
-        <p:spPr>
-          <a:xfrm>
-            <a:off x="9905695" y="6291072"/>
-            <a:ext cx="1682496" cy="365760"/>
-          </a:xfrm>
-          <a:prstGeom prst="rect">
-            <a:avLst/>
-          </a:prstGeom>
-          <a:noFill/>
-        </p:spPr>
-        <p:txBody>
-          <a:bodyPr wrap="square">
-            <a:spAutoFit/>
-          </a:bodyPr>
-          <a:lstStyle/>
-          <a:p>
-            <a:pPr algn="r"/>
-            <a:r>
-              <a:rPr sz="1100" b="0" spc="120">
-                <a:solidFill>
-                  <a:srgbClr val="6B6B6B"/>
-                </a:solidFill>
-                <a:latin typeface="IBM Plex Mono"/>
-              </a:rPr>
-              <a:t>01</a:t>
-            </a:r>
-          </a:p>
-        </p:txBody>
-      </p:sp>
     </p:spTree>
   </p:cSld>
   <p:clrMapOvr>
@@ -4129,41 +4094,6 @@
           </a:p>
         </p:txBody>
       </p:sp>
-      <p:sp>
-        <p:nvSpPr>
-          <p:cNvPr id="14" name="TextBox 13"/>
-          <p:cNvSpPr txBox="1"/>
-          <p:nvPr/>
-        </p:nvSpPr>
-        <p:spPr>
-          <a:xfrm>
-            <a:off x="9905695" y="6291072"/>
-            <a:ext cx="1682496" cy="365760"/>
-          </a:xfrm>
-          <a:prstGeom prst="rect">
-            <a:avLst/>
-          </a:prstGeom>
-          <a:noFill/>
-        </p:spPr>
-        <p:txBody>
-          <a:bodyPr wrap="square">
-            <a:spAutoFit/>
-          </a:bodyPr>
-          <a:lstStyle/>
-          <a:p>
-            <a:pPr algn="r"/>
-            <a:r>
-              <a:rPr sz="1100" b="0" spc="120">
-                <a:solidFill>
-                  <a:srgbClr val="6B6B6B"/>
-                </a:solidFill>
-                <a:latin typeface="IBM Plex Mono"/>
-              </a:rPr>
-              <a:t>11</a:t>
-            </a:r>
-          </a:p>
-        </p:txBody>
-      </p:sp>
     </p:spTree>
   </p:cSld>
   <p:clrMapOvr>
@@ -4709,41 +4639,6 @@
           </a:p>
         </p:txBody>
       </p:sp>
-      <p:sp>
-        <p:nvSpPr>
-          <p:cNvPr id="13" name="TextBox 12"/>
-          <p:cNvSpPr txBox="1"/>
-          <p:nvPr/>
-        </p:nvSpPr>
-        <p:spPr>
-          <a:xfrm>
-            <a:off x="9905695" y="6291072"/>
-            <a:ext cx="1682496" cy="365760"/>
-          </a:xfrm>
-          <a:prstGeom prst="rect">
-            <a:avLst/>
-          </a:prstGeom>
-          <a:noFill/>
-        </p:spPr>
-        <p:txBody>
-          <a:bodyPr wrap="square">
-            <a:spAutoFit/>
-          </a:bodyPr>
-          <a:lstStyle/>
-          <a:p>
-            <a:pPr algn="r"/>
-            <a:r>
-              <a:rPr sz="1100" b="0" spc="120">
-                <a:solidFill>
-                  <a:srgbClr val="6B6B6B"/>
-                </a:solidFill>
-                <a:latin typeface="IBM Plex Mono"/>
-              </a:rPr>
-              <a:t>12</a:t>
-            </a:r>
-          </a:p>
-        </p:txBody>
-      </p:sp>
     </p:spTree>
   </p:cSld>
   <p:clrMapOvr>
@@ -5463,41 +5358,6 @@
           </a:p>
         </p:txBody>
       </p:sp>
-      <p:sp>
-        <p:nvSpPr>
-          <p:cNvPr id="19" name="TextBox 18"/>
-          <p:cNvSpPr txBox="1"/>
-          <p:nvPr/>
-        </p:nvSpPr>
-        <p:spPr>
-          <a:xfrm>
-            <a:off x="9905695" y="6291072"/>
-            <a:ext cx="1682496" cy="365760"/>
-          </a:xfrm>
-          <a:prstGeom prst="rect">
-            <a:avLst/>
-          </a:prstGeom>
-          <a:noFill/>
-        </p:spPr>
-        <p:txBody>
-          <a:bodyPr wrap="square">
-            <a:spAutoFit/>
-          </a:bodyPr>
-          <a:lstStyle/>
-          <a:p>
-            <a:pPr algn="r"/>
-            <a:r>
-              <a:rPr sz="1100" b="0" spc="120">
-                <a:solidFill>
-                  <a:srgbClr val="6B6B6B"/>
-                </a:solidFill>
-                <a:latin typeface="IBM Plex Mono"/>
-              </a:rPr>
-              <a:t>13</a:t>
-            </a:r>
-          </a:p>
-        </p:txBody>
-      </p:sp>
     </p:spTree>
   </p:cSld>
   <p:clrMapOvr>
@@ -6465,41 +6325,6 @@
           </a:p>
         </p:txBody>
       </p:sp>
-      <p:sp>
-        <p:nvSpPr>
-          <p:cNvPr id="26" name="TextBox 25"/>
-          <p:cNvSpPr txBox="1"/>
-          <p:nvPr/>
-        </p:nvSpPr>
-        <p:spPr>
-          <a:xfrm>
-            <a:off x="9905695" y="6291072"/>
-            <a:ext cx="1682496" cy="365760"/>
-          </a:xfrm>
-          <a:prstGeom prst="rect">
-            <a:avLst/>
-          </a:prstGeom>
-          <a:noFill/>
-        </p:spPr>
-        <p:txBody>
-          <a:bodyPr wrap="square">
-            <a:spAutoFit/>
-          </a:bodyPr>
-          <a:lstStyle/>
-          <a:p>
-            <a:pPr algn="r"/>
-            <a:r>
-              <a:rPr sz="1100" b="0" spc="120">
-                <a:solidFill>
-                  <a:srgbClr val="6B6B6B"/>
-                </a:solidFill>
-                <a:latin typeface="IBM Plex Mono"/>
-              </a:rPr>
-              <a:t>14</a:t>
-            </a:r>
-          </a:p>
-        </p:txBody>
-      </p:sp>
     </p:spTree>
   </p:cSld>
   <p:clrMapOvr>
@@ -7355,41 +7180,6 @@
           </a:p>
         </p:txBody>
       </p:sp>
-      <p:sp>
-        <p:nvSpPr>
-          <p:cNvPr id="23" name="TextBox 22"/>
-          <p:cNvSpPr txBox="1"/>
-          <p:nvPr/>
-        </p:nvSpPr>
-        <p:spPr>
-          <a:xfrm>
-            <a:off x="9905695" y="6291072"/>
-            <a:ext cx="1682496" cy="365760"/>
-          </a:xfrm>
-          <a:prstGeom prst="rect">
-            <a:avLst/>
-          </a:prstGeom>
-          <a:noFill/>
-        </p:spPr>
-        <p:txBody>
-          <a:bodyPr wrap="square">
-            <a:spAutoFit/>
-          </a:bodyPr>
-          <a:lstStyle/>
-          <a:p>
-            <a:pPr algn="r"/>
-            <a:r>
-              <a:rPr sz="1100" b="0" spc="120">
-                <a:solidFill>
-                  <a:srgbClr val="6B6B6B"/>
-                </a:solidFill>
-                <a:latin typeface="IBM Plex Mono"/>
-              </a:rPr>
-              <a:t>15</a:t>
-            </a:r>
-          </a:p>
-        </p:txBody>
-      </p:sp>
     </p:spTree>
   </p:cSld>
   <p:clrMapOvr>
@@ -7644,41 +7434,6 @@
           </a:p>
         </p:txBody>
       </p:sp>
-      <p:sp>
-        <p:nvSpPr>
-          <p:cNvPr id="8" name="TextBox 7"/>
-          <p:cNvSpPr txBox="1"/>
-          <p:nvPr/>
-        </p:nvSpPr>
-        <p:spPr>
-          <a:xfrm>
-            <a:off x="9905695" y="6291072"/>
-            <a:ext cx="1682496" cy="365760"/>
-          </a:xfrm>
-          <a:prstGeom prst="rect">
-            <a:avLst/>
-          </a:prstGeom>
-          <a:noFill/>
-        </p:spPr>
-        <p:txBody>
-          <a:bodyPr wrap="square">
-            <a:spAutoFit/>
-          </a:bodyPr>
-          <a:lstStyle/>
-          <a:p>
-            <a:pPr algn="r"/>
-            <a:r>
-              <a:rPr sz="1100" b="0" spc="120">
-                <a:solidFill>
-                  <a:srgbClr val="6B6B6B"/>
-                </a:solidFill>
-                <a:latin typeface="IBM Plex Mono"/>
-              </a:rPr>
-              <a:t>16</a:t>
-            </a:r>
-          </a:p>
-        </p:txBody>
-      </p:sp>
     </p:spTree>
   </p:cSld>
   <p:clrMapOvr>
@@ -8534,41 +8289,6 @@
           </a:p>
         </p:txBody>
       </p:sp>
-      <p:sp>
-        <p:nvSpPr>
-          <p:cNvPr id="23" name="TextBox 22"/>
-          <p:cNvSpPr txBox="1"/>
-          <p:nvPr/>
-        </p:nvSpPr>
-        <p:spPr>
-          <a:xfrm>
-            <a:off x="9905695" y="6291072"/>
-            <a:ext cx="1682496" cy="365760"/>
-          </a:xfrm>
-          <a:prstGeom prst="rect">
-            <a:avLst/>
-          </a:prstGeom>
-          <a:noFill/>
-        </p:spPr>
-        <p:txBody>
-          <a:bodyPr wrap="square">
-            <a:spAutoFit/>
-          </a:bodyPr>
-          <a:lstStyle/>
-          <a:p>
-            <a:pPr algn="r"/>
-            <a:r>
-              <a:rPr sz="1100" b="0" spc="120">
-                <a:solidFill>
-                  <a:srgbClr val="6B6B6B"/>
-                </a:solidFill>
-                <a:latin typeface="IBM Plex Mono"/>
-              </a:rPr>
-              <a:t>17</a:t>
-            </a:r>
-          </a:p>
-        </p:txBody>
-      </p:sp>
     </p:spTree>
   </p:cSld>
   <p:clrMapOvr>
@@ -8953,41 +8673,6 @@
           </a:p>
         </p:txBody>
       </p:sp>
-      <p:sp>
-        <p:nvSpPr>
-          <p:cNvPr id="11" name="TextBox 10"/>
-          <p:cNvSpPr txBox="1"/>
-          <p:nvPr/>
-        </p:nvSpPr>
-        <p:spPr>
-          <a:xfrm>
-            <a:off x="9905695" y="6291072"/>
-            <a:ext cx="1682496" cy="365760"/>
-          </a:xfrm>
-          <a:prstGeom prst="rect">
-            <a:avLst/>
-          </a:prstGeom>
-          <a:noFill/>
-        </p:spPr>
-        <p:txBody>
-          <a:bodyPr wrap="square">
-            <a:spAutoFit/>
-          </a:bodyPr>
-          <a:lstStyle/>
-          <a:p>
-            <a:pPr algn="r"/>
-            <a:r>
-              <a:rPr sz="1100" b="0" spc="120">
-                <a:solidFill>
-                  <a:srgbClr val="6B6B6B"/>
-                </a:solidFill>
-                <a:latin typeface="IBM Plex Mono"/>
-              </a:rPr>
-              <a:t>18</a:t>
-            </a:r>
-          </a:p>
-        </p:txBody>
-      </p:sp>
     </p:spTree>
   </p:cSld>
   <p:clrMapOvr>
@@ -9260,41 +8945,6 @@
           </a:p>
         </p:txBody>
       </p:sp>
-      <p:sp>
-        <p:nvSpPr>
-          <p:cNvPr id="8" name="TextBox 7"/>
-          <p:cNvSpPr txBox="1"/>
-          <p:nvPr/>
-        </p:nvSpPr>
-        <p:spPr>
-          <a:xfrm>
-            <a:off x="9905695" y="6291072"/>
-            <a:ext cx="1682496" cy="365760"/>
-          </a:xfrm>
-          <a:prstGeom prst="rect">
-            <a:avLst/>
-          </a:prstGeom>
-          <a:noFill/>
-        </p:spPr>
-        <p:txBody>
-          <a:bodyPr wrap="square">
-            <a:spAutoFit/>
-          </a:bodyPr>
-          <a:lstStyle/>
-          <a:p>
-            <a:pPr algn="r"/>
-            <a:r>
-              <a:rPr sz="1100" b="0" spc="120">
-                <a:solidFill>
-                  <a:srgbClr val="6B6B6B"/>
-                </a:solidFill>
-                <a:latin typeface="IBM Plex Mono"/>
-              </a:rPr>
-              <a:t>19</a:t>
-            </a:r>
-          </a:p>
-        </p:txBody>
-      </p:sp>
     </p:spTree>
   </p:cSld>
   <p:clrMapOvr>
@@ -9510,41 +9160,6 @@
           </a:p>
         </p:txBody>
       </p:sp>
-      <p:sp>
-        <p:nvSpPr>
-          <p:cNvPr id="7" name="TextBox 6"/>
-          <p:cNvSpPr txBox="1"/>
-          <p:nvPr/>
-        </p:nvSpPr>
-        <p:spPr>
-          <a:xfrm>
-            <a:off x="9905695" y="6291072"/>
-            <a:ext cx="1682496" cy="365760"/>
-          </a:xfrm>
-          <a:prstGeom prst="rect">
-            <a:avLst/>
-          </a:prstGeom>
-          <a:noFill/>
-        </p:spPr>
-        <p:txBody>
-          <a:bodyPr wrap="square">
-            <a:spAutoFit/>
-          </a:bodyPr>
-          <a:lstStyle/>
-          <a:p>
-            <a:pPr algn="r"/>
-            <a:r>
-              <a:rPr sz="1100" b="0" spc="120">
-                <a:solidFill>
-                  <a:srgbClr val="BDBDBD"/>
-                </a:solidFill>
-                <a:latin typeface="IBM Plex Mono"/>
-              </a:rPr>
-              <a:t>02</a:t>
-            </a:r>
-          </a:p>
-        </p:txBody>
-      </p:sp>
     </p:spTree>
   </p:cSld>
   <p:clrMapOvr>
@@ -10175,41 +9790,6 @@
           </a:p>
         </p:txBody>
       </p:sp>
-      <p:sp>
-        <p:nvSpPr>
-          <p:cNvPr id="17" name="TextBox 16"/>
-          <p:cNvSpPr txBox="1"/>
-          <p:nvPr/>
-        </p:nvSpPr>
-        <p:spPr>
-          <a:xfrm>
-            <a:off x="9905695" y="6291072"/>
-            <a:ext cx="1682496" cy="365760"/>
-          </a:xfrm>
-          <a:prstGeom prst="rect">
-            <a:avLst/>
-          </a:prstGeom>
-          <a:noFill/>
-        </p:spPr>
-        <p:txBody>
-          <a:bodyPr wrap="square">
-            <a:spAutoFit/>
-          </a:bodyPr>
-          <a:lstStyle/>
-          <a:p>
-            <a:pPr algn="r"/>
-            <a:r>
-              <a:rPr sz="1100" b="0" spc="120">
-                <a:solidFill>
-                  <a:srgbClr val="6B6B6B"/>
-                </a:solidFill>
-                <a:latin typeface="IBM Plex Mono"/>
-              </a:rPr>
-              <a:t>03</a:t>
-            </a:r>
-          </a:p>
-        </p:txBody>
-      </p:sp>
     </p:spTree>
   </p:cSld>
   <p:clrMapOvr>
@@ -10617,41 +10197,6 @@
           </a:p>
         </p:txBody>
       </p:sp>
-      <p:sp>
-        <p:nvSpPr>
-          <p:cNvPr id="12" name="TextBox 11"/>
-          <p:cNvSpPr txBox="1"/>
-          <p:nvPr/>
-        </p:nvSpPr>
-        <p:spPr>
-          <a:xfrm>
-            <a:off x="9905695" y="6291072"/>
-            <a:ext cx="1682496" cy="365760"/>
-          </a:xfrm>
-          <a:prstGeom prst="rect">
-            <a:avLst/>
-          </a:prstGeom>
-          <a:noFill/>
-        </p:spPr>
-        <p:txBody>
-          <a:bodyPr wrap="square">
-            <a:spAutoFit/>
-          </a:bodyPr>
-          <a:lstStyle/>
-          <a:p>
-            <a:pPr algn="r"/>
-            <a:r>
-              <a:rPr sz="1100" b="0" spc="120">
-                <a:solidFill>
-                  <a:srgbClr val="6B6B6B"/>
-                </a:solidFill>
-                <a:latin typeface="IBM Plex Mono"/>
-              </a:rPr>
-              <a:t>04</a:t>
-            </a:r>
-          </a:p>
-        </p:txBody>
-      </p:sp>
     </p:spTree>
   </p:cSld>
   <p:clrMapOvr>
@@ -10911,41 +10456,6 @@
           </a:p>
         </p:txBody>
       </p:sp>
-      <p:sp>
-        <p:nvSpPr>
-          <p:cNvPr id="8" name="TextBox 7"/>
-          <p:cNvSpPr txBox="1"/>
-          <p:nvPr/>
-        </p:nvSpPr>
-        <p:spPr>
-          <a:xfrm>
-            <a:off x="9905695" y="6291072"/>
-            <a:ext cx="1682496" cy="365760"/>
-          </a:xfrm>
-          <a:prstGeom prst="rect">
-            <a:avLst/>
-          </a:prstGeom>
-          <a:noFill/>
-        </p:spPr>
-        <p:txBody>
-          <a:bodyPr wrap="square">
-            <a:spAutoFit/>
-          </a:bodyPr>
-          <a:lstStyle/>
-          <a:p>
-            <a:pPr algn="r"/>
-            <a:r>
-              <a:rPr sz="1100" b="0" spc="120">
-                <a:solidFill>
-                  <a:srgbClr val="6B6B6B"/>
-                </a:solidFill>
-                <a:latin typeface="IBM Plex Mono"/>
-              </a:rPr>
-              <a:t>05</a:t>
-            </a:r>
-          </a:p>
-        </p:txBody>
-      </p:sp>
     </p:spTree>
   </p:cSld>
   <p:clrMapOvr>
@@ -11525,41 +11035,6 @@
                 <a:latin typeface="IBM Plex Mono"/>
               </a:rPr>
               <a:t>MORTEN DS · SLIDE-TEMPLATE</a:t>
-            </a:r>
-          </a:p>
-        </p:txBody>
-      </p:sp>
-      <p:sp>
-        <p:nvSpPr>
-          <p:cNvPr id="16" name="TextBox 15"/>
-          <p:cNvSpPr txBox="1"/>
-          <p:nvPr/>
-        </p:nvSpPr>
-        <p:spPr>
-          <a:xfrm>
-            <a:off x="9905695" y="6291072"/>
-            <a:ext cx="1682496" cy="365760"/>
-          </a:xfrm>
-          <a:prstGeom prst="rect">
-            <a:avLst/>
-          </a:prstGeom>
-          <a:noFill/>
-        </p:spPr>
-        <p:txBody>
-          <a:bodyPr wrap="square">
-            <a:spAutoFit/>
-          </a:bodyPr>
-          <a:lstStyle/>
-          <a:p>
-            <a:pPr algn="r"/>
-            <a:r>
-              <a:rPr sz="1100" b="0" spc="120">
-                <a:solidFill>
-                  <a:srgbClr val="6B6B6B"/>
-                </a:solidFill>
-                <a:latin typeface="IBM Plex Mono"/>
-              </a:rPr>
-              <a:t>06</a:t>
             </a:r>
           </a:p>
         </p:txBody>
@@ -12273,41 +11748,6 @@
           </a:p>
         </p:txBody>
       </p:sp>
-      <p:sp>
-        <p:nvSpPr>
-          <p:cNvPr id="8" name="TextBox 7"/>
-          <p:cNvSpPr txBox="1"/>
-          <p:nvPr/>
-        </p:nvSpPr>
-        <p:spPr>
-          <a:xfrm>
-            <a:off x="9905695" y="6291072"/>
-            <a:ext cx="1682496" cy="365760"/>
-          </a:xfrm>
-          <a:prstGeom prst="rect">
-            <a:avLst/>
-          </a:prstGeom>
-          <a:noFill/>
-        </p:spPr>
-        <p:txBody>
-          <a:bodyPr wrap="square">
-            <a:spAutoFit/>
-          </a:bodyPr>
-          <a:lstStyle/>
-          <a:p>
-            <a:pPr algn="r"/>
-            <a:r>
-              <a:rPr sz="1100" b="0" spc="120">
-                <a:solidFill>
-                  <a:srgbClr val="6B6B6B"/>
-                </a:solidFill>
-                <a:latin typeface="IBM Plex Mono"/>
-              </a:rPr>
-              <a:t>07</a:t>
-            </a:r>
-          </a:p>
-        </p:txBody>
-      </p:sp>
     </p:spTree>
   </p:cSld>
   <p:clrMapOvr>
@@ -12975,41 +12415,6 @@
                 <a:latin typeface="IBM Plex Mono"/>
               </a:rPr>
               <a:t>MORTEN DS · SLIDE-TEMPLATE</a:t>
-            </a:r>
-          </a:p>
-        </p:txBody>
-      </p:sp>
-      <p:sp>
-        <p:nvSpPr>
-          <p:cNvPr id="19" name="TextBox 18"/>
-          <p:cNvSpPr txBox="1"/>
-          <p:nvPr/>
-        </p:nvSpPr>
-        <p:spPr>
-          <a:xfrm>
-            <a:off x="9905695" y="6291072"/>
-            <a:ext cx="1682496" cy="365760"/>
-          </a:xfrm>
-          <a:prstGeom prst="rect">
-            <a:avLst/>
-          </a:prstGeom>
-          <a:noFill/>
-        </p:spPr>
-        <p:txBody>
-          <a:bodyPr wrap="square">
-            <a:spAutoFit/>
-          </a:bodyPr>
-          <a:lstStyle/>
-          <a:p>
-            <a:pPr algn="r"/>
-            <a:r>
-              <a:rPr sz="1100" b="0" spc="120">
-                <a:solidFill>
-                  <a:srgbClr val="6B6B6B"/>
-                </a:solidFill>
-                <a:latin typeface="IBM Plex Mono"/>
-              </a:rPr>
-              <a:t>08</a:t>
             </a:r>
           </a:p>
         </p:txBody>

</xml_diff>